<commit_message>
docs: light deck uses light-theme screens of the live app on the onboarding slide
</commit_message>
<xml_diff>
--- a/docs/team/Refill-Final-Deck-Light.pptx
+++ b/docs/team/Refill-Final-Deck-Light.pptx
@@ -166,7 +166,7 @@
     </p:spTree>
     <p:extLst>
       <p:ext uri="{BB962C8B-B14F-4D97-AF65-F5344CB8AC3E}">
-        <p14:creationId xmlns:p14="http://schemas.microsoft.com/office/powerpoint/2010/main" val="3165955688"/>
+        <p14:creationId xmlns:p14="http://schemas.microsoft.com/office/powerpoint/2010/main" val="2531788198"/>
       </p:ext>
     </p:extLst>
   </p:cSld>
@@ -9611,7 +9611,7 @@
       </p:sp>
       <p:pic>
         <p:nvPicPr>
-          <p:cNvPr id="47" name="Image 0" descr="C:\Users\dhruv\AppData\Local\Temp\claude\Z--claude\2a3ee505-7da2-4081-9e72-585b4758f7b1\scratchpad\deck\art\film-desk_fit.jpg"/>
+          <p:cNvPr id="47" name="Image 0" descr="C:\Users\dhruv\AppData\Local\Temp\claude\Z--claude\2a3ee505-7da2-4081-9e72-585b4758f7b1\scratchpad\deck\art\film-desk_fit-light.jpg"/>
           <p:cNvPicPr>
             <a:picLocks noChangeAspect="1"/>
           </p:cNvPicPr>
@@ -9635,7 +9635,7 @@
       </p:pic>
       <p:pic>
         <p:nvPicPr>
-          <p:cNvPr id="48" name="Image 1" descr="C:\Users\dhruv\AppData\Local\Temp\claude\Z--claude\2a3ee505-7da2-4081-9e72-585b4758f7b1\scratchpad\deck\art\film-client.jpg"/>
+          <p:cNvPr id="48" name="Image 1" descr="C:\Users\dhruv\AppData\Local\Temp\claude\Z--claude\2a3ee505-7da2-4081-9e72-585b4758f7b1\scratchpad\deck\art\film-client-light.jpg"/>
           <p:cNvPicPr>
             <a:picLocks noChangeAspect="1"/>
           </p:cNvPicPr>
@@ -9659,7 +9659,51 @@
       </p:pic>
       <p:sp>
         <p:nvSpPr>
-          <p:cNvPr id="49" name="Text 45"/>
+          <p:cNvPr id="49" name="Shape 45"/>
+          <p:cNvSpPr/>
+          <p:nvPr/>
+        </p:nvSpPr>
+        <p:spPr>
+          <a:xfrm>
+            <a:off x="4800600" y="3794760"/>
+            <a:ext cx="1865376" cy="1051560"/>
+          </a:xfrm>
+          <a:prstGeom prst="rect">
+            <a:avLst/>
+          </a:prstGeom>
+          <a:ln w="9525">
+            <a:solidFill>
+              <a:srgbClr val="D4D2CD"/>
+            </a:solidFill>
+            <a:prstDash val="solid"/>
+          </a:ln>
+        </p:spPr>
+      </p:sp>
+      <p:sp>
+        <p:nvSpPr>
+          <p:cNvPr id="50" name="Shape 46"/>
+          <p:cNvSpPr/>
+          <p:nvPr/>
+        </p:nvSpPr>
+        <p:spPr>
+          <a:xfrm>
+            <a:off x="6867144" y="3794760"/>
+            <a:ext cx="1865376" cy="1051560"/>
+          </a:xfrm>
+          <a:prstGeom prst="rect">
+            <a:avLst/>
+          </a:prstGeom>
+          <a:ln w="9525">
+            <a:solidFill>
+              <a:srgbClr val="D4D2CD"/>
+            </a:solidFill>
+            <a:prstDash val="solid"/>
+          </a:ln>
+        </p:spPr>
+      </p:sp>
+      <p:sp>
+        <p:nvSpPr>
+          <p:cNvPr id="51" name="Text 47"/>
           <p:cNvSpPr txBox="1"/>
           <p:nvPr/>
         </p:nvSpPr>
@@ -9698,7 +9742,7 @@
       </p:sp>
       <p:sp>
         <p:nvSpPr>
-          <p:cNvPr id="50" name="Text 46"/>
+          <p:cNvPr id="52" name="Text 48"/>
           <p:cNvSpPr txBox="1"/>
           <p:nvPr/>
         </p:nvSpPr>
@@ -9737,7 +9781,7 @@
       </p:sp>
       <p:sp>
         <p:nvSpPr>
-          <p:cNvPr id="51" name="Slide Number Placeholder 0"/>
+          <p:cNvPr id="53" name="Slide Number Placeholder 0"/>
           <p:cNvSpPr>
             <a:spLocks noGrp="1"/>
           </p:cNvSpPr>

</xml_diff>